<commit_message>
Add JanMitra presentation deck and technical architecture flowcharts
</commit_message>
<xml_diff>
--- a/JanMitra_Presentation.pptx
+++ b/JanMitra_Presentation.pptx
@@ -3145,7 +3145,7 @@
         </p:nvSpPr>
         <p:spPr>
           <a:xfrm>
-            <a:off x="1097280" y="1097280"/>
+            <a:off x="1097280" y="1188720"/>
             <a:ext cx="9966960" cy="2926080"/>
           </a:xfrm>
           <a:prstGeom prst="rect">
@@ -3160,59 +3160,44 @@
           <a:lstStyle/>
           <a:p>
             <a:pPr>
-              <a:defRPr sz="1200" b="1">
-                <a:solidFill>
-                  <a:srgbClr val="F59E0B"/>
-                </a:solidFill>
-              </a:defRPr>
-            </a:pPr>
-            <a:r>
-              <a:t>CIVIC-TECH INNOVATION  •  INDIA &amp; UTTAR PRADESH PROTOTYPE</a:t>
+              <a:defRPr sz="4800" b="1">
+                <a:solidFill>
+                  <a:srgbClr val="FFFFFF"/>
+                </a:solidFill>
+              </a:defRPr>
+            </a:pPr>
+            <a:r>
+              <a:t>JanMitra (जनमित्र)</a:t>
             </a:r>
           </a:p>
           <a:p>
             <a:pPr>
               <a:spcBef>
-                <a:spcPts val="800"/>
+                <a:spcPts val="600"/>
               </a:spcBef>
-              <a:defRPr sz="4600" b="1">
-                <a:solidFill>
-                  <a:srgbClr val="FFFFFF"/>
-                </a:solidFill>
-              </a:defRPr>
-            </a:pPr>
-            <a:r>
-              <a:t>JanMitra (जनमित्र)</a:t>
+              <a:defRPr sz="2200">
+                <a:solidFill>
+                  <a:srgbClr val="BFDBFE"/>
+                </a:solidFill>
+              </a:defRPr>
+            </a:pPr>
+            <a:r>
+              <a:t>“Understand. Discover. Apply.”</a:t>
             </a:r>
           </a:p>
           <a:p>
             <a:pPr>
               <a:spcBef>
-                <a:spcPts val="400"/>
+                <a:spcPts val="1000"/>
               </a:spcBef>
-              <a:defRPr sz="2000">
-                <a:solidFill>
-                  <a:srgbClr val="BFDBFE"/>
-                </a:solidFill>
-              </a:defRPr>
-            </a:pPr>
-            <a:r>
-              <a:t>“Understand. Discover. Apply.”</a:t>
-            </a:r>
-          </a:p>
-          <a:p>
-            <a:pPr>
-              <a:spcBef>
-                <a:spcPts val="800"/>
-              </a:spcBef>
-              <a:defRPr sz="1400">
+              <a:defRPr sz="1500">
                 <a:solidFill>
                   <a:srgbClr val="CBD5E1"/>
                 </a:solidFill>
               </a:defRPr>
             </a:pPr>
             <a:r>
-              <a:t>A personalized civic navigation platform that transforms everyday citizen problems into evidence-backed government action plans.</a:t>
+              <a:t>A citizen-first digital navigator that turns real-life situations into evidence-backed government action plans.</a:t>
             </a:r>
           </a:p>
         </p:txBody>
@@ -3338,8 +3323,8 @@
         </p:nvSpPr>
         <p:spPr>
           <a:xfrm>
-            <a:off x="731520" y="365760"/>
-            <a:ext cx="10698480" cy="320040"/>
+            <a:off x="731520" y="502920"/>
+            <a:ext cx="10698480" cy="548640"/>
           </a:xfrm>
           <a:prstGeom prst="rect">
             <a:avLst/>
@@ -3353,14 +3338,14 @@
           <a:lstStyle/>
           <a:p>
             <a:pPr>
-              <a:defRPr sz="1100" b="1">
-                <a:solidFill>
-                  <a:srgbClr val="D97706"/>
-                </a:solidFill>
-              </a:defRPr>
-            </a:pPr>
-            <a:r>
-              <a:t>THE CITIZEN CHALLENGE</a:t>
+              <a:defRPr sz="2400" b="1">
+                <a:solidFill>
+                  <a:srgbClr val="0F172A"/>
+                </a:solidFill>
+              </a:defRPr>
+            </a:pPr>
+            <a:r>
+              <a:t>The Reality of Accessing Government Welfare in India</a:t>
             </a:r>
           </a:p>
         </p:txBody>
@@ -3373,8 +3358,8 @@
         </p:nvSpPr>
         <p:spPr>
           <a:xfrm>
-            <a:off x="731520" y="685800"/>
-            <a:ext cx="10698480" cy="502920"/>
+            <a:off x="731520" y="1051560"/>
+            <a:ext cx="10698480" cy="411480"/>
           </a:xfrm>
           <a:prstGeom prst="rect">
             <a:avLst/>
@@ -3388,14 +3373,14 @@
           <a:lstStyle/>
           <a:p>
             <a:pPr>
-              <a:defRPr sz="2200" b="1">
-                <a:solidFill>
-                  <a:srgbClr val="0F172A"/>
-                </a:solidFill>
-              </a:defRPr>
-            </a:pPr>
-            <a:r>
-              <a:t>The Reality of Accessing Government Welfare in India</a:t>
+              <a:defRPr sz="1300">
+                <a:solidFill>
+                  <a:srgbClr val="64748B"/>
+                </a:solidFill>
+              </a:defRPr>
+            </a:pPr>
+            <a:r>
+              <a:t>Why billions in public welfare budgets remain unutilized by eligible citizens</a:t>
             </a:r>
           </a:p>
         </p:txBody>
@@ -3403,41 +3388,6 @@
       <p:sp>
         <p:nvSpPr>
           <p:cNvPr id="4" name="TextBox 3"/>
-          <p:cNvSpPr txBox="1"/>
-          <p:nvPr/>
-        </p:nvSpPr>
-        <p:spPr>
-          <a:xfrm>
-            <a:off x="731520" y="1188720"/>
-            <a:ext cx="10698480" cy="365760"/>
-          </a:xfrm>
-          <a:prstGeom prst="rect">
-            <a:avLst/>
-          </a:prstGeom>
-          <a:noFill/>
-        </p:spPr>
-        <p:txBody>
-          <a:bodyPr wrap="square">
-            <a:spAutoFit/>
-          </a:bodyPr>
-          <a:lstStyle/>
-          <a:p>
-            <a:pPr>
-              <a:defRPr sz="1200">
-                <a:solidFill>
-                  <a:srgbClr val="64748B"/>
-                </a:solidFill>
-              </a:defRPr>
-            </a:pPr>
-            <a:r>
-              <a:t>Why billions in public welfare budgets remain unutilized by eligible citizens</a:t>
-            </a:r>
-          </a:p>
-        </p:txBody>
-      </p:sp>
-      <p:sp>
-        <p:nvSpPr>
-          <p:cNvPr id="5" name="TextBox 4"/>
           <p:cNvSpPr txBox="1"/>
           <p:nvPr/>
         </p:nvSpPr>
@@ -3465,21 +3415,21 @@
               </a:defRPr>
             </a:pPr>
             <a:r>
-              <a:t>JanMitra: Understand. Discover. Apply.  |  Slide 2 of 7</a:t>
-            </a:r>
-          </a:p>
-        </p:txBody>
-      </p:sp>
-      <p:sp>
-        <p:nvSpPr>
-          <p:cNvPr id="6" name="Rounded Rectangle 5"/>
+              <a:t>JanMitra  •  Slide 2 of 7</a:t>
+            </a:r>
+          </a:p>
+        </p:txBody>
+      </p:sp>
+      <p:sp>
+        <p:nvSpPr>
+          <p:cNvPr id="5" name="Rounded Rectangle 4"/>
           <p:cNvSpPr/>
           <p:nvPr/>
         </p:nvSpPr>
         <p:spPr>
           <a:xfrm>
-            <a:off x="731520" y="1737360"/>
-            <a:ext cx="5120640" cy="1920240"/>
+            <a:off x="731520" y="1691640"/>
+            <a:ext cx="5120640" cy="1965960"/>
           </a:xfrm>
           <a:prstGeom prst="roundRect">
             <a:avLst/>
@@ -3517,14 +3467,14 @@
       </p:sp>
       <p:sp>
         <p:nvSpPr>
-          <p:cNvPr id="7" name="TextBox 6"/>
+          <p:cNvPr id="6" name="TextBox 5"/>
           <p:cNvSpPr txBox="1"/>
           <p:nvPr/>
         </p:nvSpPr>
         <p:spPr>
           <a:xfrm>
-            <a:off x="1005840" y="1920240"/>
-            <a:ext cx="4572000" cy="1554480"/>
+            <a:off x="1005840" y="1874520"/>
+            <a:ext cx="4572000" cy="1600200"/>
           </a:xfrm>
           <a:prstGeom prst="rect">
             <a:avLst/>
@@ -3560,21 +3510,21 @@
               </a:defRPr>
             </a:pPr>
             <a:r>
-              <a:t>Schemes are siloed across hundreds of separate department portals. Citizens must already know the scheme acronym (PMAY, MMYSY, NFSA) to search.</a:t>
-            </a:r>
-          </a:p>
-        </p:txBody>
-      </p:sp>
-      <p:sp>
-        <p:nvSpPr>
-          <p:cNvPr id="8" name="Rounded Rectangle 7"/>
+              <a:t>Schemes are siloed across hundreds of separate department portals. Citizens must already know the scheme acronym (PMAY, MMYSY, NFSA) before searching.</a:t>
+            </a:r>
+          </a:p>
+        </p:txBody>
+      </p:sp>
+      <p:sp>
+        <p:nvSpPr>
+          <p:cNvPr id="7" name="Rounded Rectangle 6"/>
           <p:cNvSpPr/>
           <p:nvPr/>
         </p:nvSpPr>
         <p:spPr>
           <a:xfrm>
-            <a:off x="6126480" y="1737360"/>
-            <a:ext cx="5120640" cy="1920240"/>
+            <a:off x="6126480" y="1691640"/>
+            <a:ext cx="5120640" cy="1965960"/>
           </a:xfrm>
           <a:prstGeom prst="roundRect">
             <a:avLst/>
@@ -3612,14 +3562,14 @@
       </p:sp>
       <p:sp>
         <p:nvSpPr>
-          <p:cNvPr id="9" name="TextBox 8"/>
+          <p:cNvPr id="8" name="TextBox 7"/>
           <p:cNvSpPr txBox="1"/>
           <p:nvPr/>
         </p:nvSpPr>
         <p:spPr>
           <a:xfrm>
-            <a:off x="6400800" y="1920240"/>
-            <a:ext cx="4572000" cy="1554480"/>
+            <a:off x="6400800" y="1874520"/>
+            <a:ext cx="4572000" cy="1600200"/>
           </a:xfrm>
           <a:prstGeom prst="rect">
             <a:avLst/>
@@ -3655,21 +3605,21 @@
               </a:defRPr>
             </a:pPr>
             <a:r>
-              <a:t>Official circulars, affidavits, and gazette notices are written in dense bureaucratic prose that excludes first-time digital and rural citizens.</a:t>
-            </a:r>
-          </a:p>
-        </p:txBody>
-      </p:sp>
-      <p:sp>
-        <p:nvSpPr>
-          <p:cNvPr id="10" name="Rounded Rectangle 9"/>
+              <a:t>Official circulars, affidavits, and gazette notices use dense bureaucratic prose that intimidates first-time digital and rural citizens.</a:t>
+            </a:r>
+          </a:p>
+        </p:txBody>
+      </p:sp>
+      <p:sp>
+        <p:nvSpPr>
+          <p:cNvPr id="9" name="Rounded Rectangle 8"/>
           <p:cNvSpPr/>
           <p:nvPr/>
         </p:nvSpPr>
         <p:spPr>
           <a:xfrm>
             <a:off x="731520" y="3931920"/>
-            <a:ext cx="5120640" cy="1920240"/>
+            <a:ext cx="5120640" cy="1965960"/>
           </a:xfrm>
           <a:prstGeom prst="roundRect">
             <a:avLst/>
@@ -3707,14 +3657,14 @@
       </p:sp>
       <p:sp>
         <p:nvSpPr>
-          <p:cNvPr id="11" name="TextBox 10"/>
+          <p:cNvPr id="10" name="TextBox 9"/>
           <p:cNvSpPr txBox="1"/>
           <p:nvPr/>
         </p:nvSpPr>
         <p:spPr>
           <a:xfrm>
             <a:off x="1005840" y="4114800"/>
-            <a:ext cx="4572000" cy="1554480"/>
+            <a:ext cx="4572000" cy="1600200"/>
           </a:xfrm>
           <a:prstGeom prst="rect">
             <a:avLst/>
@@ -3757,14 +3707,14 @@
       </p:sp>
       <p:sp>
         <p:nvSpPr>
-          <p:cNvPr id="12" name="Rounded Rectangle 11"/>
+          <p:cNvPr id="11" name="Rounded Rectangle 10"/>
           <p:cNvSpPr/>
           <p:nvPr/>
         </p:nvSpPr>
         <p:spPr>
           <a:xfrm>
             <a:off x="6126480" y="3931920"/>
-            <a:ext cx="5120640" cy="1920240"/>
+            <a:ext cx="5120640" cy="1965960"/>
           </a:xfrm>
           <a:prstGeom prst="roundRect">
             <a:avLst/>
@@ -3802,14 +3752,14 @@
       </p:sp>
       <p:sp>
         <p:nvSpPr>
-          <p:cNvPr id="13" name="TextBox 12"/>
+          <p:cNvPr id="12" name="TextBox 11"/>
           <p:cNvSpPr txBox="1"/>
           <p:nvPr/>
         </p:nvSpPr>
         <p:spPr>
           <a:xfrm>
             <a:off x="6400800" y="4114800"/>
-            <a:ext cx="4572000" cy="1554480"/>
+            <a:ext cx="4572000" cy="1600200"/>
           </a:xfrm>
           <a:prstGeom prst="rect">
             <a:avLst/>
@@ -3845,7 +3795,7 @@
               </a:defRPr>
             </a:pPr>
             <a:r>
-              <a:t>Citizens are forced to rely on unverified touts, while generic AI chatbots hallucinate fake URLs, wrong deadlines, and non-existent rules.</a:t>
+              <a:t>Citizens are forced to pay unverified touts, while generic AI chatbots hallucinate fake URLs, wrong deadlines, and non-existent rules.</a:t>
             </a:r>
           </a:p>
         </p:txBody>
@@ -3876,8 +3826,8 @@
         </p:nvSpPr>
         <p:spPr>
           <a:xfrm>
-            <a:off x="731520" y="365760"/>
-            <a:ext cx="10698480" cy="320040"/>
+            <a:off x="731520" y="502920"/>
+            <a:ext cx="10698480" cy="548640"/>
           </a:xfrm>
           <a:prstGeom prst="rect">
             <a:avLst/>
@@ -3891,14 +3841,14 @@
           <a:lstStyle/>
           <a:p>
             <a:pPr>
-              <a:defRPr sz="1100" b="1">
-                <a:solidFill>
-                  <a:srgbClr val="D97706"/>
-                </a:solidFill>
-              </a:defRPr>
-            </a:pPr>
-            <a:r>
-              <a:t>COMPETITIVE BENCHMARKING</a:t>
+              <a:defRPr sz="2400" b="1">
+                <a:solidFill>
+                  <a:srgbClr val="0F172A"/>
+                </a:solidFill>
+              </a:defRPr>
+            </a:pPr>
+            <a:r>
+              <a:t>Traditional Portals vs. Generic AI vs. JanMitra</a:t>
             </a:r>
           </a:p>
         </p:txBody>
@@ -3911,8 +3861,8 @@
         </p:nvSpPr>
         <p:spPr>
           <a:xfrm>
-            <a:off x="731520" y="685800"/>
-            <a:ext cx="10698480" cy="502920"/>
+            <a:off x="731520" y="1051560"/>
+            <a:ext cx="10698480" cy="411480"/>
           </a:xfrm>
           <a:prstGeom prst="rect">
             <a:avLst/>
@@ -3926,14 +3876,14 @@
           <a:lstStyle/>
           <a:p>
             <a:pPr>
-              <a:defRPr sz="2200" b="1">
-                <a:solidFill>
-                  <a:srgbClr val="0F172A"/>
-                </a:solidFill>
-              </a:defRPr>
-            </a:pPr>
-            <a:r>
-              <a:t>Traditional Portals vs. Generic AI vs. JanMitra</a:t>
+              <a:defRPr sz="1300">
+                <a:solidFill>
+                  <a:srgbClr val="64748B"/>
+                </a:solidFill>
+              </a:defRPr>
+            </a:pPr>
+            <a:r>
+              <a:t>Why JanMitra is fundamentally superior to both search portals and generic AI chatbots</a:t>
             </a:r>
           </a:p>
         </p:txBody>
@@ -3941,41 +3891,6 @@
       <p:sp>
         <p:nvSpPr>
           <p:cNvPr id="4" name="TextBox 3"/>
-          <p:cNvSpPr txBox="1"/>
-          <p:nvPr/>
-        </p:nvSpPr>
-        <p:spPr>
-          <a:xfrm>
-            <a:off x="731520" y="1188720"/>
-            <a:ext cx="10698480" cy="365760"/>
-          </a:xfrm>
-          <a:prstGeom prst="rect">
-            <a:avLst/>
-          </a:prstGeom>
-          <a:noFill/>
-        </p:spPr>
-        <p:txBody>
-          <a:bodyPr wrap="square">
-            <a:spAutoFit/>
-          </a:bodyPr>
-          <a:lstStyle/>
-          <a:p>
-            <a:pPr>
-              <a:defRPr sz="1200">
-                <a:solidFill>
-                  <a:srgbClr val="64748B"/>
-                </a:solidFill>
-              </a:defRPr>
-            </a:pPr>
-            <a:r>
-              <a:t>Why JanMitra is fundamentally superior to both search portals and generic AI chatbots</a:t>
-            </a:r>
-          </a:p>
-        </p:txBody>
-      </p:sp>
-      <p:sp>
-        <p:nvSpPr>
-          <p:cNvPr id="5" name="TextBox 4"/>
           <p:cNvSpPr txBox="1"/>
           <p:nvPr/>
         </p:nvSpPr>
@@ -4003,21 +3918,21 @@
               </a:defRPr>
             </a:pPr>
             <a:r>
-              <a:t>JanMitra: Understand. Discover. Apply.  |  Slide 3 of 7</a:t>
-            </a:r>
-          </a:p>
-        </p:txBody>
-      </p:sp>
-      <p:sp>
-        <p:nvSpPr>
-          <p:cNvPr id="6" name="Rounded Rectangle 5"/>
+              <a:t>JanMitra  •  Slide 3 of 7</a:t>
+            </a:r>
+          </a:p>
+        </p:txBody>
+      </p:sp>
+      <p:sp>
+        <p:nvSpPr>
+          <p:cNvPr id="5" name="Rounded Rectangle 4"/>
           <p:cNvSpPr/>
           <p:nvPr/>
         </p:nvSpPr>
         <p:spPr>
           <a:xfrm>
-            <a:off x="731520" y="1691640"/>
-            <a:ext cx="3474720" cy="4572000"/>
+            <a:off x="731520" y="1645920"/>
+            <a:ext cx="3474720" cy="4617720"/>
           </a:xfrm>
           <a:prstGeom prst="roundRect">
             <a:avLst/>
@@ -4055,14 +3970,14 @@
       </p:sp>
       <p:sp>
         <p:nvSpPr>
-          <p:cNvPr id="7" name="TextBox 6"/>
+          <p:cNvPr id="6" name="TextBox 5"/>
           <p:cNvSpPr txBox="1"/>
           <p:nvPr/>
         </p:nvSpPr>
         <p:spPr>
           <a:xfrm>
-            <a:off x="914400" y="1783080"/>
-            <a:ext cx="3108960" cy="4297680"/>
+            <a:off x="914400" y="1737360"/>
+            <a:ext cx="3108960" cy="4343400"/>
           </a:xfrm>
           <a:prstGeom prst="rect">
             <a:avLst/>
@@ -4255,14 +4170,14 @@
       </p:sp>
       <p:sp>
         <p:nvSpPr>
-          <p:cNvPr id="8" name="Rounded Rectangle 7"/>
+          <p:cNvPr id="7" name="Rounded Rectangle 6"/>
           <p:cNvSpPr/>
           <p:nvPr/>
         </p:nvSpPr>
         <p:spPr>
           <a:xfrm>
-            <a:off x="4343400" y="1691640"/>
-            <a:ext cx="3474720" cy="4572000"/>
+            <a:off x="4343400" y="1645920"/>
+            <a:ext cx="3474720" cy="4617720"/>
           </a:xfrm>
           <a:prstGeom prst="roundRect">
             <a:avLst/>
@@ -4300,14 +4215,14 @@
       </p:sp>
       <p:sp>
         <p:nvSpPr>
-          <p:cNvPr id="9" name="TextBox 8"/>
+          <p:cNvPr id="8" name="TextBox 7"/>
           <p:cNvSpPr txBox="1"/>
           <p:nvPr/>
         </p:nvSpPr>
         <p:spPr>
           <a:xfrm>
-            <a:off x="4526280" y="1783080"/>
-            <a:ext cx="3108960" cy="4297680"/>
+            <a:off x="4526280" y="1737360"/>
+            <a:ext cx="3108960" cy="4343400"/>
           </a:xfrm>
           <a:prstGeom prst="rect">
             <a:avLst/>
@@ -4500,14 +4415,14 @@
       </p:sp>
       <p:sp>
         <p:nvSpPr>
-          <p:cNvPr id="10" name="Rounded Rectangle 9"/>
+          <p:cNvPr id="9" name="Rounded Rectangle 8"/>
           <p:cNvSpPr/>
           <p:nvPr/>
         </p:nvSpPr>
         <p:spPr>
           <a:xfrm>
-            <a:off x="7955280" y="1691640"/>
-            <a:ext cx="3474720" cy="4572000"/>
+            <a:off x="7955280" y="1645920"/>
+            <a:ext cx="3474720" cy="4617720"/>
           </a:xfrm>
           <a:prstGeom prst="roundRect">
             <a:avLst/>
@@ -4545,14 +4460,14 @@
       </p:sp>
       <p:sp>
         <p:nvSpPr>
-          <p:cNvPr id="11" name="TextBox 10"/>
+          <p:cNvPr id="10" name="TextBox 9"/>
           <p:cNvSpPr txBox="1"/>
           <p:nvPr/>
         </p:nvSpPr>
         <p:spPr>
           <a:xfrm>
-            <a:off x="8138160" y="1783080"/>
-            <a:ext cx="3108960" cy="4297680"/>
+            <a:off x="8138160" y="1737360"/>
+            <a:ext cx="3108960" cy="4343400"/>
           </a:xfrm>
           <a:prstGeom prst="rect">
             <a:avLst/>
@@ -4769,8 +4684,8 @@
         </p:nvSpPr>
         <p:spPr>
           <a:xfrm>
-            <a:off x="731520" y="365760"/>
-            <a:ext cx="10698480" cy="320040"/>
+            <a:off x="731520" y="502920"/>
+            <a:ext cx="10698480" cy="548640"/>
           </a:xfrm>
           <a:prstGeom prst="rect">
             <a:avLst/>
@@ -4784,14 +4699,14 @@
           <a:lstStyle/>
           <a:p>
             <a:pPr>
-              <a:defRPr sz="1100" b="1">
-                <a:solidFill>
-                  <a:srgbClr val="D97706"/>
-                </a:solidFill>
-              </a:defRPr>
-            </a:pPr>
-            <a:r>
-              <a:t>FROM IDEA TO IMPACT</a:t>
+              <a:defRPr sz="2400" b="1">
+                <a:solidFill>
+                  <a:srgbClr val="0F172A"/>
+                </a:solidFill>
+              </a:defRPr>
+            </a:pPr>
+            <a:r>
+              <a:t>The Paradigm Shift &amp; The 8-Stage Action Loop</a:t>
             </a:r>
           </a:p>
         </p:txBody>
@@ -4804,8 +4719,8 @@
         </p:nvSpPr>
         <p:spPr>
           <a:xfrm>
-            <a:off x="731520" y="685800"/>
-            <a:ext cx="10698480" cy="502920"/>
+            <a:off x="731520" y="1051560"/>
+            <a:ext cx="10698480" cy="411480"/>
           </a:xfrm>
           <a:prstGeom prst="rect">
             <a:avLst/>
@@ -4819,14 +4734,14 @@
           <a:lstStyle/>
           <a:p>
             <a:pPr>
-              <a:defRPr sz="2200" b="1">
-                <a:solidFill>
-                  <a:srgbClr val="0F172A"/>
-                </a:solidFill>
-              </a:defRPr>
-            </a:pPr>
-            <a:r>
-              <a:t>The Paradigm Shift &amp; The 8-Stage Action Loop</a:t>
+              <a:defRPr sz="1300">
+                <a:solidFill>
+                  <a:srgbClr val="64748B"/>
+                </a:solidFill>
+              </a:defRPr>
+            </a:pPr>
+            <a:r>
+              <a:t>Transforming ambiguous citizen dilemmas into completed government sanctions</a:t>
             </a:r>
           </a:p>
         </p:txBody>
@@ -4834,41 +4749,6 @@
       <p:sp>
         <p:nvSpPr>
           <p:cNvPr id="4" name="TextBox 3"/>
-          <p:cNvSpPr txBox="1"/>
-          <p:nvPr/>
-        </p:nvSpPr>
-        <p:spPr>
-          <a:xfrm>
-            <a:off x="731520" y="1188720"/>
-            <a:ext cx="10698480" cy="365760"/>
-          </a:xfrm>
-          <a:prstGeom prst="rect">
-            <a:avLst/>
-          </a:prstGeom>
-          <a:noFill/>
-        </p:spPr>
-        <p:txBody>
-          <a:bodyPr wrap="square">
-            <a:spAutoFit/>
-          </a:bodyPr>
-          <a:lstStyle/>
-          <a:p>
-            <a:pPr>
-              <a:defRPr sz="1200">
-                <a:solidFill>
-                  <a:srgbClr val="64748B"/>
-                </a:solidFill>
-              </a:defRPr>
-            </a:pPr>
-            <a:r>
-              <a:t>Transforming ambiguous citizen dilemmas into completed government sanctions</a:t>
-            </a:r>
-          </a:p>
-        </p:txBody>
-      </p:sp>
-      <p:sp>
-        <p:nvSpPr>
-          <p:cNvPr id="5" name="TextBox 4"/>
           <p:cNvSpPr txBox="1"/>
           <p:nvPr/>
         </p:nvSpPr>
@@ -4896,20 +4776,20 @@
               </a:defRPr>
             </a:pPr>
             <a:r>
-              <a:t>JanMitra: Understand. Discover. Apply.  |  Slide 4 of 7</a:t>
-            </a:r>
-          </a:p>
-        </p:txBody>
-      </p:sp>
-      <p:sp>
-        <p:nvSpPr>
-          <p:cNvPr id="6" name="Rounded Rectangle 5"/>
+              <a:t>JanMitra  •  Slide 4 of 7</a:t>
+            </a:r>
+          </a:p>
+        </p:txBody>
+      </p:sp>
+      <p:sp>
+        <p:nvSpPr>
+          <p:cNvPr id="5" name="Rounded Rectangle 4"/>
           <p:cNvSpPr/>
           <p:nvPr/>
         </p:nvSpPr>
         <p:spPr>
           <a:xfrm>
-            <a:off x="731520" y="1691640"/>
+            <a:off x="731520" y="1645920"/>
             <a:ext cx="10698480" cy="1280160"/>
           </a:xfrm>
           <a:prstGeom prst="roundRect">
@@ -4948,13 +4828,13 @@
       </p:sp>
       <p:sp>
         <p:nvSpPr>
-          <p:cNvPr id="7" name="TextBox 6"/>
+          <p:cNvPr id="6" name="TextBox 5"/>
           <p:cNvSpPr txBox="1"/>
           <p:nvPr/>
         </p:nvSpPr>
         <p:spPr>
           <a:xfrm>
-            <a:off x="914400" y="1783080"/>
+            <a:off x="914400" y="1737360"/>
             <a:ext cx="10332720" cy="1097280"/>
           </a:xfrm>
           <a:prstGeom prst="rect">
@@ -5013,13 +4893,13 @@
       </p:sp>
       <p:sp>
         <p:nvSpPr>
-          <p:cNvPr id="8" name="Rounded Rectangle 7"/>
+          <p:cNvPr id="7" name="Rounded Rectangle 6"/>
           <p:cNvSpPr/>
           <p:nvPr/>
         </p:nvSpPr>
         <p:spPr>
           <a:xfrm>
-            <a:off x="731520" y="3154680"/>
+            <a:off x="731520" y="3108960"/>
             <a:ext cx="2560320" cy="1371600"/>
           </a:xfrm>
           <a:prstGeom prst="roundRect">
@@ -5058,13 +4938,13 @@
       </p:sp>
       <p:sp>
         <p:nvSpPr>
-          <p:cNvPr id="9" name="TextBox 8"/>
+          <p:cNvPr id="8" name="TextBox 7"/>
           <p:cNvSpPr txBox="1"/>
           <p:nvPr/>
         </p:nvSpPr>
         <p:spPr>
           <a:xfrm>
-            <a:off x="914400" y="3264408"/>
+            <a:off x="914400" y="3218688"/>
             <a:ext cx="2194560" cy="1097280"/>
           </a:xfrm>
           <a:prstGeom prst="rect">
@@ -5120,13 +5000,13 @@
       </p:sp>
       <p:sp>
         <p:nvSpPr>
-          <p:cNvPr id="10" name="Rounded Rectangle 9"/>
+          <p:cNvPr id="9" name="Rounded Rectangle 8"/>
           <p:cNvSpPr/>
           <p:nvPr/>
         </p:nvSpPr>
         <p:spPr>
           <a:xfrm>
-            <a:off x="3429000" y="3154680"/>
+            <a:off x="3429000" y="3108960"/>
             <a:ext cx="2560320" cy="1371600"/>
           </a:xfrm>
           <a:prstGeom prst="roundRect">
@@ -5165,13 +5045,13 @@
       </p:sp>
       <p:sp>
         <p:nvSpPr>
-          <p:cNvPr id="11" name="TextBox 10"/>
+          <p:cNvPr id="10" name="TextBox 9"/>
           <p:cNvSpPr txBox="1"/>
           <p:nvPr/>
         </p:nvSpPr>
         <p:spPr>
           <a:xfrm>
-            <a:off x="3611880" y="3264408"/>
+            <a:off x="3611880" y="3218688"/>
             <a:ext cx="2194560" cy="1097280"/>
           </a:xfrm>
           <a:prstGeom prst="rect">
@@ -5227,13 +5107,13 @@
       </p:sp>
       <p:sp>
         <p:nvSpPr>
-          <p:cNvPr id="12" name="Rounded Rectangle 11"/>
+          <p:cNvPr id="11" name="Rounded Rectangle 10"/>
           <p:cNvSpPr/>
           <p:nvPr/>
         </p:nvSpPr>
         <p:spPr>
           <a:xfrm>
-            <a:off x="6126480" y="3154680"/>
+            <a:off x="6126480" y="3108960"/>
             <a:ext cx="2560320" cy="1371600"/>
           </a:xfrm>
           <a:prstGeom prst="roundRect">
@@ -5272,13 +5152,13 @@
       </p:sp>
       <p:sp>
         <p:nvSpPr>
-          <p:cNvPr id="13" name="TextBox 12"/>
+          <p:cNvPr id="12" name="TextBox 11"/>
           <p:cNvSpPr txBox="1"/>
           <p:nvPr/>
         </p:nvSpPr>
         <p:spPr>
           <a:xfrm>
-            <a:off x="6309360" y="3264408"/>
+            <a:off x="6309360" y="3218688"/>
             <a:ext cx="2194560" cy="1097280"/>
           </a:xfrm>
           <a:prstGeom prst="rect">
@@ -5334,13 +5214,13 @@
       </p:sp>
       <p:sp>
         <p:nvSpPr>
-          <p:cNvPr id="14" name="Rounded Rectangle 13"/>
+          <p:cNvPr id="13" name="Rounded Rectangle 12"/>
           <p:cNvSpPr/>
           <p:nvPr/>
         </p:nvSpPr>
         <p:spPr>
           <a:xfrm>
-            <a:off x="8823960" y="3154680"/>
+            <a:off x="8823960" y="3108960"/>
             <a:ext cx="2560320" cy="1371600"/>
           </a:xfrm>
           <a:prstGeom prst="roundRect">
@@ -5379,13 +5259,13 @@
       </p:sp>
       <p:sp>
         <p:nvSpPr>
-          <p:cNvPr id="15" name="TextBox 14"/>
+          <p:cNvPr id="14" name="TextBox 13"/>
           <p:cNvSpPr txBox="1"/>
           <p:nvPr/>
         </p:nvSpPr>
         <p:spPr>
           <a:xfrm>
-            <a:off x="9006840" y="3264408"/>
+            <a:off x="9006840" y="3218688"/>
             <a:ext cx="2194560" cy="1097280"/>
           </a:xfrm>
           <a:prstGeom prst="rect">
@@ -5441,13 +5321,13 @@
       </p:sp>
       <p:sp>
         <p:nvSpPr>
-          <p:cNvPr id="16" name="Rounded Rectangle 15"/>
+          <p:cNvPr id="15" name="Rounded Rectangle 14"/>
           <p:cNvSpPr/>
           <p:nvPr/>
         </p:nvSpPr>
         <p:spPr>
           <a:xfrm>
-            <a:off x="731520" y="4709160"/>
+            <a:off x="731520" y="4663440"/>
             <a:ext cx="2560320" cy="1371600"/>
           </a:xfrm>
           <a:prstGeom prst="roundRect">
@@ -5486,13 +5366,13 @@
       </p:sp>
       <p:sp>
         <p:nvSpPr>
-          <p:cNvPr id="17" name="TextBox 16"/>
+          <p:cNvPr id="16" name="TextBox 15"/>
           <p:cNvSpPr txBox="1"/>
           <p:nvPr/>
         </p:nvSpPr>
         <p:spPr>
           <a:xfrm>
-            <a:off x="914400" y="4818888"/>
+            <a:off x="914400" y="4773168"/>
             <a:ext cx="2194560" cy="1097280"/>
           </a:xfrm>
           <a:prstGeom prst="rect">
@@ -5548,13 +5428,13 @@
       </p:sp>
       <p:sp>
         <p:nvSpPr>
-          <p:cNvPr id="18" name="Rounded Rectangle 17"/>
+          <p:cNvPr id="17" name="Rounded Rectangle 16"/>
           <p:cNvSpPr/>
           <p:nvPr/>
         </p:nvSpPr>
         <p:spPr>
           <a:xfrm>
-            <a:off x="3429000" y="4709160"/>
+            <a:off x="3429000" y="4663440"/>
             <a:ext cx="2560320" cy="1371600"/>
           </a:xfrm>
           <a:prstGeom prst="roundRect">
@@ -5593,13 +5473,13 @@
       </p:sp>
       <p:sp>
         <p:nvSpPr>
-          <p:cNvPr id="19" name="TextBox 18"/>
+          <p:cNvPr id="18" name="TextBox 17"/>
           <p:cNvSpPr txBox="1"/>
           <p:nvPr/>
         </p:nvSpPr>
         <p:spPr>
           <a:xfrm>
-            <a:off x="3611880" y="4818888"/>
+            <a:off x="3611880" y="4773168"/>
             <a:ext cx="2194560" cy="1097280"/>
           </a:xfrm>
           <a:prstGeom prst="rect">
@@ -5655,13 +5535,13 @@
       </p:sp>
       <p:sp>
         <p:nvSpPr>
-          <p:cNvPr id="20" name="Rounded Rectangle 19"/>
+          <p:cNvPr id="19" name="Rounded Rectangle 18"/>
           <p:cNvSpPr/>
           <p:nvPr/>
         </p:nvSpPr>
         <p:spPr>
           <a:xfrm>
-            <a:off x="6126480" y="4709160"/>
+            <a:off x="6126480" y="4663440"/>
             <a:ext cx="2560320" cy="1371600"/>
           </a:xfrm>
           <a:prstGeom prst="roundRect">
@@ -5700,13 +5580,13 @@
       </p:sp>
       <p:sp>
         <p:nvSpPr>
-          <p:cNvPr id="21" name="TextBox 20"/>
+          <p:cNvPr id="20" name="TextBox 19"/>
           <p:cNvSpPr txBox="1"/>
           <p:nvPr/>
         </p:nvSpPr>
         <p:spPr>
           <a:xfrm>
-            <a:off x="6309360" y="4818888"/>
+            <a:off x="6309360" y="4773168"/>
             <a:ext cx="2194560" cy="1097280"/>
           </a:xfrm>
           <a:prstGeom prst="rect">
@@ -5762,13 +5642,13 @@
       </p:sp>
       <p:sp>
         <p:nvSpPr>
-          <p:cNvPr id="22" name="Rounded Rectangle 21"/>
+          <p:cNvPr id="21" name="Rounded Rectangle 20"/>
           <p:cNvSpPr/>
           <p:nvPr/>
         </p:nvSpPr>
         <p:spPr>
           <a:xfrm>
-            <a:off x="8823960" y="4709160"/>
+            <a:off x="8823960" y="4663440"/>
             <a:ext cx="2560320" cy="1371600"/>
           </a:xfrm>
           <a:prstGeom prst="roundRect">
@@ -5807,13 +5687,13 @@
       </p:sp>
       <p:sp>
         <p:nvSpPr>
-          <p:cNvPr id="23" name="TextBox 22"/>
+          <p:cNvPr id="22" name="TextBox 21"/>
           <p:cNvSpPr txBox="1"/>
           <p:nvPr/>
         </p:nvSpPr>
         <p:spPr>
           <a:xfrm>
-            <a:off x="9006840" y="4818888"/>
+            <a:off x="9006840" y="4773168"/>
             <a:ext cx="2194560" cy="1097280"/>
           </a:xfrm>
           <a:prstGeom prst="rect">
@@ -5893,8 +5773,8 @@
         </p:nvSpPr>
         <p:spPr>
           <a:xfrm>
-            <a:off x="731520" y="365760"/>
-            <a:ext cx="10698480" cy="320040"/>
+            <a:off x="731520" y="502920"/>
+            <a:ext cx="10698480" cy="548640"/>
           </a:xfrm>
           <a:prstGeom prst="rect">
             <a:avLst/>
@@ -5908,14 +5788,14 @@
           <a:lstStyle/>
           <a:p>
             <a:pPr>
-              <a:defRPr sz="1100" b="1">
-                <a:solidFill>
-                  <a:srgbClr val="D97706"/>
-                </a:solidFill>
-              </a:defRPr>
-            </a:pPr>
-            <a:r>
-              <a:t>PROTOTYPE CAPABILITIES</a:t>
+              <a:defRPr sz="2400" b="1">
+                <a:solidFill>
+                  <a:srgbClr val="0F172A"/>
+                </a:solidFill>
+              </a:defRPr>
+            </a:pPr>
+            <a:r>
+              <a:t>Core Platform Features &amp; Live User Workflows</a:t>
             </a:r>
           </a:p>
         </p:txBody>
@@ -5928,8 +5808,8 @@
         </p:nvSpPr>
         <p:spPr>
           <a:xfrm>
-            <a:off x="731520" y="685800"/>
-            <a:ext cx="10698480" cy="502920"/>
+            <a:off x="731520" y="1051560"/>
+            <a:ext cx="10698480" cy="411480"/>
           </a:xfrm>
           <a:prstGeom prst="rect">
             <a:avLst/>
@@ -5943,14 +5823,14 @@
           <a:lstStyle/>
           <a:p>
             <a:pPr>
-              <a:defRPr sz="2200" b="1">
-                <a:solidFill>
-                  <a:srgbClr val="0F172A"/>
-                </a:solidFill>
-              </a:defRPr>
-            </a:pPr>
-            <a:r>
-              <a:t>Core Platform Features &amp; Live User Workflows</a:t>
+              <a:defRPr sz="1300">
+                <a:solidFill>
+                  <a:srgbClr val="64748B"/>
+                </a:solidFill>
+              </a:defRPr>
+            </a:pPr>
+            <a:r>
+              <a:t>Demonstrated and tested across 12+ schemes, 8+ public services, and 16+ credentials</a:t>
             </a:r>
           </a:p>
         </p:txBody>
@@ -5958,41 +5838,6 @@
       <p:sp>
         <p:nvSpPr>
           <p:cNvPr id="4" name="TextBox 3"/>
-          <p:cNvSpPr txBox="1"/>
-          <p:nvPr/>
-        </p:nvSpPr>
-        <p:spPr>
-          <a:xfrm>
-            <a:off x="731520" y="1188720"/>
-            <a:ext cx="10698480" cy="365760"/>
-          </a:xfrm>
-          <a:prstGeom prst="rect">
-            <a:avLst/>
-          </a:prstGeom>
-          <a:noFill/>
-        </p:spPr>
-        <p:txBody>
-          <a:bodyPr wrap="square">
-            <a:spAutoFit/>
-          </a:bodyPr>
-          <a:lstStyle/>
-          <a:p>
-            <a:pPr>
-              <a:defRPr sz="1200">
-                <a:solidFill>
-                  <a:srgbClr val="64748B"/>
-                </a:solidFill>
-              </a:defRPr>
-            </a:pPr>
-            <a:r>
-              <a:t>Demonstrated and tested across 12+ schemes, 8+ public services, and 16+ credentials</a:t>
-            </a:r>
-          </a:p>
-        </p:txBody>
-      </p:sp>
-      <p:sp>
-        <p:nvSpPr>
-          <p:cNvPr id="5" name="TextBox 4"/>
           <p:cNvSpPr txBox="1"/>
           <p:nvPr/>
         </p:nvSpPr>
@@ -6020,21 +5865,21 @@
               </a:defRPr>
             </a:pPr>
             <a:r>
-              <a:t>JanMitra: Understand. Discover. Apply.  |  Slide 5 of 7</a:t>
-            </a:r>
-          </a:p>
-        </p:txBody>
-      </p:sp>
-      <p:sp>
-        <p:nvSpPr>
-          <p:cNvPr id="6" name="Rounded Rectangle 5"/>
+              <a:t>JanMitra  •  Slide 5 of 7</a:t>
+            </a:r>
+          </a:p>
+        </p:txBody>
+      </p:sp>
+      <p:sp>
+        <p:nvSpPr>
+          <p:cNvPr id="5" name="Rounded Rectangle 4"/>
           <p:cNvSpPr/>
           <p:nvPr/>
         </p:nvSpPr>
         <p:spPr>
           <a:xfrm>
-            <a:off x="731520" y="1737360"/>
-            <a:ext cx="3429000" cy="1920240"/>
+            <a:off x="731520" y="1691640"/>
+            <a:ext cx="3429000" cy="1965960"/>
           </a:xfrm>
           <a:prstGeom prst="roundRect">
             <a:avLst/>
@@ -6072,14 +5917,14 @@
       </p:sp>
       <p:sp>
         <p:nvSpPr>
-          <p:cNvPr id="7" name="TextBox 6"/>
+          <p:cNvPr id="6" name="TextBox 5"/>
           <p:cNvSpPr txBox="1"/>
           <p:nvPr/>
         </p:nvSpPr>
         <p:spPr>
           <a:xfrm>
-            <a:off x="914400" y="1874520"/>
-            <a:ext cx="3063240" cy="1645920"/>
+            <a:off x="914400" y="1828800"/>
+            <a:ext cx="3063240" cy="1691640"/>
           </a:xfrm>
           <a:prstGeom prst="rect">
             <a:avLst/>
@@ -6122,14 +5967,14 @@
       </p:sp>
       <p:sp>
         <p:nvSpPr>
-          <p:cNvPr id="8" name="Rounded Rectangle 7"/>
+          <p:cNvPr id="7" name="Rounded Rectangle 6"/>
           <p:cNvSpPr/>
           <p:nvPr/>
         </p:nvSpPr>
         <p:spPr>
           <a:xfrm>
-            <a:off x="4343400" y="1737360"/>
-            <a:ext cx="3429000" cy="1920240"/>
+            <a:off x="4343400" y="1691640"/>
+            <a:ext cx="3429000" cy="1965960"/>
           </a:xfrm>
           <a:prstGeom prst="roundRect">
             <a:avLst/>
@@ -6167,14 +6012,14 @@
       </p:sp>
       <p:sp>
         <p:nvSpPr>
-          <p:cNvPr id="9" name="TextBox 8"/>
+          <p:cNvPr id="8" name="TextBox 7"/>
           <p:cNvSpPr txBox="1"/>
           <p:nvPr/>
         </p:nvSpPr>
         <p:spPr>
           <a:xfrm>
-            <a:off x="4526280" y="1874520"/>
-            <a:ext cx="3063240" cy="1645920"/>
+            <a:off x="4526280" y="1828800"/>
+            <a:ext cx="3063240" cy="1691640"/>
           </a:xfrm>
           <a:prstGeom prst="rect">
             <a:avLst/>
@@ -6217,14 +6062,14 @@
       </p:sp>
       <p:sp>
         <p:nvSpPr>
-          <p:cNvPr id="10" name="Rounded Rectangle 9"/>
+          <p:cNvPr id="9" name="Rounded Rectangle 8"/>
           <p:cNvSpPr/>
           <p:nvPr/>
         </p:nvSpPr>
         <p:spPr>
           <a:xfrm>
-            <a:off x="7955280" y="1737360"/>
-            <a:ext cx="3429000" cy="1920240"/>
+            <a:off x="7955280" y="1691640"/>
+            <a:ext cx="3429000" cy="1965960"/>
           </a:xfrm>
           <a:prstGeom prst="roundRect">
             <a:avLst/>
@@ -6262,14 +6107,14 @@
       </p:sp>
       <p:sp>
         <p:nvSpPr>
-          <p:cNvPr id="11" name="TextBox 10"/>
+          <p:cNvPr id="10" name="TextBox 9"/>
           <p:cNvSpPr txBox="1"/>
           <p:nvPr/>
         </p:nvSpPr>
         <p:spPr>
           <a:xfrm>
-            <a:off x="8138160" y="1874520"/>
-            <a:ext cx="3063240" cy="1645920"/>
+            <a:off x="8138160" y="1828800"/>
+            <a:ext cx="3063240" cy="1691640"/>
           </a:xfrm>
           <a:prstGeom prst="rect">
             <a:avLst/>
@@ -6312,14 +6157,14 @@
       </p:sp>
       <p:sp>
         <p:nvSpPr>
-          <p:cNvPr id="12" name="Rounded Rectangle 11"/>
+          <p:cNvPr id="11" name="Rounded Rectangle 10"/>
           <p:cNvSpPr/>
           <p:nvPr/>
         </p:nvSpPr>
         <p:spPr>
           <a:xfrm>
-            <a:off x="731520" y="3840479"/>
-            <a:ext cx="3429000" cy="1920240"/>
+            <a:off x="731520" y="3840480"/>
+            <a:ext cx="3429000" cy="1965960"/>
           </a:xfrm>
           <a:prstGeom prst="roundRect">
             <a:avLst/>
@@ -6357,14 +6202,14 @@
       </p:sp>
       <p:sp>
         <p:nvSpPr>
-          <p:cNvPr id="13" name="TextBox 12"/>
+          <p:cNvPr id="12" name="TextBox 11"/>
           <p:cNvSpPr txBox="1"/>
           <p:nvPr/>
         </p:nvSpPr>
         <p:spPr>
           <a:xfrm>
-            <a:off x="914400" y="3977639"/>
-            <a:ext cx="3063240" cy="1645920"/>
+            <a:off x="914400" y="3977640"/>
+            <a:ext cx="3063240" cy="1691640"/>
           </a:xfrm>
           <a:prstGeom prst="rect">
             <a:avLst/>
@@ -6407,14 +6252,14 @@
       </p:sp>
       <p:sp>
         <p:nvSpPr>
-          <p:cNvPr id="14" name="Rounded Rectangle 13"/>
+          <p:cNvPr id="13" name="Rounded Rectangle 12"/>
           <p:cNvSpPr/>
           <p:nvPr/>
         </p:nvSpPr>
         <p:spPr>
           <a:xfrm>
-            <a:off x="4343400" y="3840479"/>
-            <a:ext cx="3429000" cy="1920240"/>
+            <a:off x="4343400" y="3840480"/>
+            <a:ext cx="3429000" cy="1965960"/>
           </a:xfrm>
           <a:prstGeom prst="roundRect">
             <a:avLst/>
@@ -6452,14 +6297,14 @@
       </p:sp>
       <p:sp>
         <p:nvSpPr>
-          <p:cNvPr id="15" name="TextBox 14"/>
+          <p:cNvPr id="14" name="TextBox 13"/>
           <p:cNvSpPr txBox="1"/>
           <p:nvPr/>
         </p:nvSpPr>
         <p:spPr>
           <a:xfrm>
-            <a:off x="4526280" y="3977639"/>
-            <a:ext cx="3063240" cy="1645920"/>
+            <a:off x="4526280" y="3977640"/>
+            <a:ext cx="3063240" cy="1691640"/>
           </a:xfrm>
           <a:prstGeom prst="rect">
             <a:avLst/>
@@ -6502,14 +6347,14 @@
       </p:sp>
       <p:sp>
         <p:nvSpPr>
-          <p:cNvPr id="16" name="Rounded Rectangle 15"/>
+          <p:cNvPr id="15" name="Rounded Rectangle 14"/>
           <p:cNvSpPr/>
           <p:nvPr/>
         </p:nvSpPr>
         <p:spPr>
           <a:xfrm>
-            <a:off x="7955280" y="3840479"/>
-            <a:ext cx="3429000" cy="1920240"/>
+            <a:off x="7955280" y="3840480"/>
+            <a:ext cx="3429000" cy="1965960"/>
           </a:xfrm>
           <a:prstGeom prst="roundRect">
             <a:avLst/>
@@ -6547,14 +6392,14 @@
       </p:sp>
       <p:sp>
         <p:nvSpPr>
-          <p:cNvPr id="17" name="TextBox 16"/>
+          <p:cNvPr id="16" name="TextBox 15"/>
           <p:cNvSpPr txBox="1"/>
           <p:nvPr/>
         </p:nvSpPr>
         <p:spPr>
           <a:xfrm>
-            <a:off x="8138160" y="3977639"/>
-            <a:ext cx="3063240" cy="1645920"/>
+            <a:off x="8138160" y="3977640"/>
+            <a:ext cx="3063240" cy="1691640"/>
           </a:xfrm>
           <a:prstGeom prst="rect">
             <a:avLst/>
@@ -6621,8 +6466,8 @@
         </p:nvSpPr>
         <p:spPr>
           <a:xfrm>
-            <a:off x="731520" y="365760"/>
-            <a:ext cx="10698480" cy="320040"/>
+            <a:off x="731520" y="502920"/>
+            <a:ext cx="10698480" cy="548640"/>
           </a:xfrm>
           <a:prstGeom prst="rect">
             <a:avLst/>
@@ -6636,14 +6481,14 @@
           <a:lstStyle/>
           <a:p>
             <a:pPr>
-              <a:defRPr sz="1100" b="1">
-                <a:solidFill>
-                  <a:srgbClr val="D97706"/>
-                </a:solidFill>
-              </a:defRPr>
-            </a:pPr>
-            <a:r>
-              <a:t>ARCHITECTURE &amp; TRUST ENGINE</a:t>
+              <a:defRPr sz="2400" b="1">
+                <a:solidFill>
+                  <a:srgbClr val="0F172A"/>
+                </a:solidFill>
+              </a:defRPr>
+            </a:pPr>
+            <a:r>
+              <a:t>Technical Stack, Evidence-First Trust &amp; Implementation</a:t>
             </a:r>
           </a:p>
         </p:txBody>
@@ -6656,8 +6501,8 @@
         </p:nvSpPr>
         <p:spPr>
           <a:xfrm>
-            <a:off x="731520" y="685800"/>
-            <a:ext cx="10698480" cy="502920"/>
+            <a:off x="731520" y="1051560"/>
+            <a:ext cx="10698480" cy="411480"/>
           </a:xfrm>
           <a:prstGeom prst="rect">
             <a:avLst/>
@@ -6671,14 +6516,14 @@
           <a:lstStyle/>
           <a:p>
             <a:pPr>
-              <a:defRPr sz="2200" b="1">
-                <a:solidFill>
-                  <a:srgbClr val="0F172A"/>
-                </a:solidFill>
-              </a:defRPr>
-            </a:pPr>
-            <a:r>
-              <a:t>Technical Stack, Evidence-First Provenance &amp; DPI Integration</a:t>
+              <a:defRPr sz="1300">
+                <a:solidFill>
+                  <a:srgbClr val="64748B"/>
+                </a:solidFill>
+              </a:defRPr>
+            </a:pPr>
+            <a:r>
+              <a:t>Engineered for speed, mathematical correctness, privacy sovereignty, and national scale</a:t>
             </a:r>
           </a:p>
         </p:txBody>
@@ -6686,41 +6531,6 @@
       <p:sp>
         <p:nvSpPr>
           <p:cNvPr id="4" name="TextBox 3"/>
-          <p:cNvSpPr txBox="1"/>
-          <p:nvPr/>
-        </p:nvSpPr>
-        <p:spPr>
-          <a:xfrm>
-            <a:off x="731520" y="1188720"/>
-            <a:ext cx="10698480" cy="365760"/>
-          </a:xfrm>
-          <a:prstGeom prst="rect">
-            <a:avLst/>
-          </a:prstGeom>
-          <a:noFill/>
-        </p:spPr>
-        <p:txBody>
-          <a:bodyPr wrap="square">
-            <a:spAutoFit/>
-          </a:bodyPr>
-          <a:lstStyle/>
-          <a:p>
-            <a:pPr>
-              <a:defRPr sz="1200">
-                <a:solidFill>
-                  <a:srgbClr val="64748B"/>
-                </a:solidFill>
-              </a:defRPr>
-            </a:pPr>
-            <a:r>
-              <a:t>Engineered for speed, mathematical correctness, privacy sovereignty, and national scale</a:t>
-            </a:r>
-          </a:p>
-        </p:txBody>
-      </p:sp>
-      <p:sp>
-        <p:nvSpPr>
-          <p:cNvPr id="5" name="TextBox 4"/>
           <p:cNvSpPr txBox="1"/>
           <p:nvPr/>
         </p:nvSpPr>
@@ -6748,21 +6558,21 @@
               </a:defRPr>
             </a:pPr>
             <a:r>
-              <a:t>JanMitra: Understand. Discover. Apply.  |  Slide 6 of 7</a:t>
-            </a:r>
-          </a:p>
-        </p:txBody>
-      </p:sp>
-      <p:sp>
-        <p:nvSpPr>
-          <p:cNvPr id="6" name="Rounded Rectangle 5"/>
+              <a:t>JanMitra  •  Slide 6 of 7</a:t>
+            </a:r>
+          </a:p>
+        </p:txBody>
+      </p:sp>
+      <p:sp>
+        <p:nvSpPr>
+          <p:cNvPr id="5" name="Rounded Rectangle 4"/>
           <p:cNvSpPr/>
           <p:nvPr/>
         </p:nvSpPr>
         <p:spPr>
           <a:xfrm>
-            <a:off x="731520" y="1737360"/>
-            <a:ext cx="5120640" cy="1920240"/>
+            <a:off x="731520" y="1691640"/>
+            <a:ext cx="5120640" cy="1965960"/>
           </a:xfrm>
           <a:prstGeom prst="roundRect">
             <a:avLst/>
@@ -6800,14 +6610,14 @@
       </p:sp>
       <p:sp>
         <p:nvSpPr>
-          <p:cNvPr id="7" name="TextBox 6"/>
+          <p:cNvPr id="6" name="TextBox 5"/>
           <p:cNvSpPr txBox="1"/>
           <p:nvPr/>
         </p:nvSpPr>
         <p:spPr>
           <a:xfrm>
-            <a:off x="1005840" y="1874520"/>
-            <a:ext cx="4572000" cy="1645920"/>
+            <a:off x="1005840" y="1828800"/>
+            <a:ext cx="4572000" cy="1691640"/>
           </a:xfrm>
           <a:prstGeom prst="rect">
             <a:avLst/>
@@ -6862,14 +6672,14 @@
       </p:sp>
       <p:sp>
         <p:nvSpPr>
-          <p:cNvPr id="8" name="Rounded Rectangle 7"/>
+          <p:cNvPr id="7" name="Rounded Rectangle 6"/>
           <p:cNvSpPr/>
           <p:nvPr/>
         </p:nvSpPr>
         <p:spPr>
           <a:xfrm>
-            <a:off x="6126480" y="1737360"/>
-            <a:ext cx="5120640" cy="1920240"/>
+            <a:off x="6126480" y="1691640"/>
+            <a:ext cx="5120640" cy="1965960"/>
           </a:xfrm>
           <a:prstGeom prst="roundRect">
             <a:avLst/>
@@ -6907,14 +6717,14 @@
       </p:sp>
       <p:sp>
         <p:nvSpPr>
-          <p:cNvPr id="9" name="TextBox 8"/>
+          <p:cNvPr id="8" name="TextBox 7"/>
           <p:cNvSpPr txBox="1"/>
           <p:nvPr/>
         </p:nvSpPr>
         <p:spPr>
           <a:xfrm>
-            <a:off x="6400800" y="1874520"/>
-            <a:ext cx="4572000" cy="1645920"/>
+            <a:off x="6400800" y="1828800"/>
+            <a:ext cx="4572000" cy="1691640"/>
           </a:xfrm>
           <a:prstGeom prst="rect">
             <a:avLst/>
@@ -6969,14 +6779,14 @@
       </p:sp>
       <p:sp>
         <p:nvSpPr>
-          <p:cNvPr id="10" name="Rounded Rectangle 9"/>
+          <p:cNvPr id="9" name="Rounded Rectangle 8"/>
           <p:cNvSpPr/>
           <p:nvPr/>
         </p:nvSpPr>
         <p:spPr>
           <a:xfrm>
             <a:off x="731520" y="3931920"/>
-            <a:ext cx="5120640" cy="1920240"/>
+            <a:ext cx="5120640" cy="1965960"/>
           </a:xfrm>
           <a:prstGeom prst="roundRect">
             <a:avLst/>
@@ -7014,14 +6824,14 @@
       </p:sp>
       <p:sp>
         <p:nvSpPr>
-          <p:cNvPr id="11" name="TextBox 10"/>
+          <p:cNvPr id="10" name="TextBox 9"/>
           <p:cNvSpPr txBox="1"/>
           <p:nvPr/>
         </p:nvSpPr>
         <p:spPr>
           <a:xfrm>
             <a:off x="1005840" y="4069080"/>
-            <a:ext cx="4572000" cy="1645920"/>
+            <a:ext cx="4572000" cy="1691640"/>
           </a:xfrm>
           <a:prstGeom prst="rect">
             <a:avLst/>
@@ -7076,14 +6886,14 @@
       </p:sp>
       <p:sp>
         <p:nvSpPr>
-          <p:cNvPr id="12" name="Rounded Rectangle 11"/>
+          <p:cNvPr id="11" name="Rounded Rectangle 10"/>
           <p:cNvSpPr/>
           <p:nvPr/>
         </p:nvSpPr>
         <p:spPr>
           <a:xfrm>
             <a:off x="6126480" y="3931920"/>
-            <a:ext cx="5120640" cy="1920240"/>
+            <a:ext cx="5120640" cy="1965960"/>
           </a:xfrm>
           <a:prstGeom prst="roundRect">
             <a:avLst/>
@@ -7121,14 +6931,14 @@
       </p:sp>
       <p:sp>
         <p:nvSpPr>
-          <p:cNvPr id="13" name="TextBox 12"/>
+          <p:cNvPr id="12" name="TextBox 11"/>
           <p:cNvSpPr txBox="1"/>
           <p:nvPr/>
         </p:nvSpPr>
         <p:spPr>
           <a:xfrm>
             <a:off x="6400800" y="4069080"/>
-            <a:ext cx="4572000" cy="1645920"/>
+            <a:ext cx="4572000" cy="1691640"/>
           </a:xfrm>
           <a:prstGeom prst="rect">
             <a:avLst/>
@@ -7265,22 +7075,7 @@
           <a:lstStyle/>
           <a:p>
             <a:pPr>
-              <a:defRPr sz="1200" b="1">
-                <a:solidFill>
-                  <a:srgbClr val="F59E0B"/>
-                </a:solidFill>
-              </a:defRPr>
-            </a:pPr>
-            <a:r>
-              <a:t>TRANSFORMATIVE CITIZEN IMPACT  •  FROM IDEA TO IMPACT</a:t>
-            </a:r>
-          </a:p>
-          <a:p>
-            <a:pPr>
-              <a:spcBef>
-                <a:spcPts val="400"/>
-              </a:spcBef>
-              <a:defRPr sz="3000" b="1">
+              <a:defRPr sz="3200" b="1">
                 <a:solidFill>
                   <a:srgbClr val="FFFFFF"/>
                 </a:solidFill>

</xml_diff>